<commit_message>
fix(deck): логотип Vector Ray в движке — 15 дек Vector Legal (D2)
Правило №2 README объявляет логотип обязательным на титульном слайде, но
engine.py его не рисовал: 15 дек vector-legal шли без логотипа. Правило и
код расходились; выбрано приведение кода к правилу.

- engine.py, s_title: логотип f'{ASSETS}/vector_ray_t.png', 0.9″, y=0.30″,
  ПОСЛЕ арта и текста (z-order). Позиция адаптивная: при half-арте справа
  сверху — лого слева (0.55″), иначе справа (12.20″).
- tests/smoke_build.py: check_logo вызывается для 15 тем движка, не только
  для музыкальных дек. Мутация «убрать логотип» роняет тест — 15 ошибок.
- Пересобраны 15 дек и render/ (192 PNG, 12 на тему, 1920×1081), контактные
  листы обновлены. Титулы тёмных (01, 05, 07) и светлых (06, 11, 12) тем
  прочитаны по рендеру: логотип виден, наложений на эмблему/текст нет.
  Эталон 00-v2-original не тронут.

Проверки: smoke_build — 15 тем, 0 ошибок.
</commit_message>
<xml_diff>
--- a/vector-legal-01-obsidian-neon.pptx
+++ b/vector-legal-01-obsidian-neon.pptx
@@ -3993,6 +3993,30 @@
           </a:p>
         </p:txBody>
       </p:sp>
+      <p:pic>
+        <p:nvPicPr>
+          <p:cNvPr id="25" name="Picture 24" descr="vector_ray_t.png"/>
+          <p:cNvPicPr>
+            <a:picLocks noChangeAspect="1"/>
+          </p:cNvPicPr>
+          <p:nvPr/>
+        </p:nvPicPr>
+        <p:blipFill>
+          <a:blip r:embed="rId3"/>
+          <a:stretch>
+            <a:fillRect/>
+          </a:stretch>
+        </p:blipFill>
+        <p:spPr>
+          <a:xfrm>
+            <a:off x="11155680" y="274320"/>
+            <a:ext cx="822960" cy="582402"/>
+          </a:xfrm>
+          <a:prstGeom prst="rect">
+            <a:avLst/>
+          </a:prstGeom>
+        </p:spPr>
+      </p:pic>
     </p:spTree>
   </p:cSld>
   <p:clrMapOvr>

</xml_diff>